<commit_message>
Update team and final deck
</commit_message>
<xml_diff>
--- a/HomeWard_DevFest_Pitch_Deck_Final.pptx
+++ b/HomeWard_DevFest_Pitch_Deck_Final.pptx
@@ -2560,8 +2560,8 @@
         </p:nvSpPr>
         <p:spPr>
           <a:xfrm>
-            <a:off x="7818120" y="4050792"/>
-            <a:ext cx="2697480" cy="493776"/>
+            <a:off x="7818120" y="3977640"/>
+            <a:ext cx="2697480" cy="713232"/>
           </a:xfrm>
           <a:prstGeom prst="rect">
             <a:avLst/>
@@ -2579,7 +2579,7 @@
               <a:buNone/>
             </a:pPr>
             <a:r>
-              <a:rPr lang="en-US" sz="1150" dirty="0">
+              <a:rPr lang="en-US" sz="1050" dirty="0">
                 <a:solidFill>
                   <a:srgbClr val="FFFFFF"/>
                 </a:solidFill>
@@ -2589,14 +2589,14 @@
               </a:rPr>
               <a:t>Kamwanga Raheem</a:t>
             </a:r>
-            <a:endParaRPr lang="en-US" sz="1150" dirty="0"/>
+            <a:endParaRPr lang="en-US" sz="1050" dirty="0"/>
           </a:p>
           <a:p>
             <a:pPr algn="ctr" indent="0" marL="0">
               <a:buNone/>
             </a:pPr>
             <a:r>
-              <a:rPr lang="en-US" sz="1150" dirty="0">
+              <a:rPr lang="en-US" sz="1050" dirty="0">
                 <a:solidFill>
                   <a:srgbClr val="FFFFFF"/>
                 </a:solidFill>
@@ -2606,14 +2606,14 @@
               </a:rPr>
               <a:t>Kisakye Abigail</a:t>
             </a:r>
-            <a:endParaRPr lang="en-US" sz="1150" dirty="0"/>
+            <a:endParaRPr lang="en-US" sz="1050" dirty="0"/>
           </a:p>
           <a:p>
             <a:pPr algn="ctr" indent="0" marL="0">
               <a:buNone/>
             </a:pPr>
             <a:r>
-              <a:rPr lang="en-US" sz="1150" dirty="0">
+              <a:rPr lang="en-US" sz="1050" dirty="0">
                 <a:solidFill>
                   <a:srgbClr val="FFFFFF"/>
                 </a:solidFill>
@@ -2623,7 +2623,24 @@
               </a:rPr>
               <a:t>Sunday Emmanuel Lugai</a:t>
             </a:r>
-            <a:endParaRPr lang="en-US" sz="1150" dirty="0"/>
+            <a:endParaRPr lang="en-US" sz="1050" dirty="0"/>
+          </a:p>
+          <a:p>
+            <a:pPr algn="ctr" indent="0" marL="0">
+              <a:buNone/>
+            </a:pPr>
+            <a:r>
+              <a:rPr lang="en-US" sz="1050" dirty="0">
+                <a:solidFill>
+                  <a:srgbClr val="FFFFFF"/>
+                </a:solidFill>
+                <a:latin typeface="Aptos" pitchFamily="34" charset="0"/>
+                <a:ea typeface="Aptos" pitchFamily="34" charset="-122"/>
+                <a:cs typeface="Aptos" pitchFamily="34" charset="-120"/>
+              </a:rPr>
+              <a:t>Kaboggoza Ivan</a:t>
+            </a:r>
+            <a:endParaRPr lang="en-US" sz="1050" dirty="0"/>
           </a:p>
         </p:txBody>
       </p:sp>

</xml_diff>